<commit_message>
add link to install SecurePass
</commit_message>
<xml_diff>
--- a/SecurePassPresentation.pptx
+++ b/SecurePassPresentation.pptx
@@ -5197,10 +5197,10 @@
           <a:lstStyle/>
           <a:p>
             <a:fld id="{CC057153-B650-4DEB-B370-79DDCFDCE934}" type="slidenum">
-              <a:rPr lang="en-US" smtClean="0"/>
+              <a:rPr lang="en-US" sz="1100" smtClean="0"/>
               <a:t>1</a:t>
             </a:fld>
-            <a:endParaRPr lang="en-US"/>
+            <a:endParaRPr lang="en-US" sz="1100" dirty="0"/>
           </a:p>
         </p:txBody>
       </p:sp>
@@ -5399,14 +5399,14 @@
           <a:lstStyle/>
           <a:p>
             <a:fld id="{CC057153-B650-4DEB-B370-79DDCFDCE934}" type="slidenum">
-              <a:rPr lang="en-US" smtClean="0">
+              <a:rPr lang="en-US" sz="1100" smtClean="0">
                 <a:solidFill>
                   <a:schemeClr val="bg1"/>
                 </a:solidFill>
               </a:rPr>
               <a:t>10</a:t>
             </a:fld>
-            <a:endParaRPr lang="en-US" dirty="0">
+            <a:endParaRPr lang="en-US" sz="1100" dirty="0">
               <a:solidFill>
                 <a:schemeClr val="bg1"/>
               </a:solidFill>
@@ -5609,14 +5609,14 @@
           <a:lstStyle/>
           <a:p>
             <a:fld id="{CC057153-B650-4DEB-B370-79DDCFDCE934}" type="slidenum">
-              <a:rPr lang="en-US" smtClean="0">
+              <a:rPr lang="en-US" sz="1100" smtClean="0">
                 <a:solidFill>
                   <a:schemeClr val="bg1"/>
                 </a:solidFill>
               </a:rPr>
               <a:t>11</a:t>
             </a:fld>
-            <a:endParaRPr lang="en-US" dirty="0">
+            <a:endParaRPr lang="en-US" sz="1100" dirty="0">
               <a:solidFill>
                 <a:schemeClr val="bg1"/>
               </a:solidFill>
@@ -5762,14 +5762,14 @@
           <a:lstStyle/>
           <a:p>
             <a:fld id="{CC057153-B650-4DEB-B370-79DDCFDCE934}" type="slidenum">
-              <a:rPr lang="en-US" smtClean="0">
+              <a:rPr lang="en-US" sz="1100" smtClean="0">
                 <a:solidFill>
                   <a:schemeClr val="bg1"/>
                 </a:solidFill>
               </a:rPr>
               <a:t>12</a:t>
             </a:fld>
-            <a:endParaRPr lang="en-US" dirty="0">
+            <a:endParaRPr lang="en-US" sz="1100" dirty="0">
               <a:solidFill>
                 <a:schemeClr val="bg1"/>
               </a:solidFill>
@@ -5871,7 +5871,7 @@
           <a:lstStyle/>
           <a:p>
             <a:r>
-              <a:rPr lang="en-US" sz="2400" dirty="0">
+              <a:rPr lang="en-US" sz="2800" dirty="0">
                 <a:solidFill>
                   <a:schemeClr val="bg1"/>
                 </a:solidFill>
@@ -5879,7 +5879,7 @@
               <a:t>Weak passwords </a:t>
             </a:r>
             <a:r>
-              <a:rPr lang="en-US" sz="2400" dirty="0">
+              <a:rPr lang="en-US" sz="2800" dirty="0">
                 <a:solidFill>
                   <a:schemeClr val="bg1"/>
                 </a:solidFill>
@@ -5890,7 +5890,7 @@
           </a:p>
           <a:p>
             <a:r>
-              <a:rPr lang="en-US" sz="2400" dirty="0">
+              <a:rPr lang="en-US" sz="2800" dirty="0">
                 <a:solidFill>
                   <a:schemeClr val="bg1"/>
                 </a:solidFill>
@@ -5901,7 +5901,7 @@
           </a:p>
           <a:p>
             <a:r>
-              <a:rPr lang="en-US" sz="2400" dirty="0">
+              <a:rPr lang="en-US" sz="2800" dirty="0">
                 <a:solidFill>
                   <a:schemeClr val="bg1"/>
                 </a:solidFill>
@@ -5912,7 +5912,7 @@
           </a:p>
           <a:p>
             <a:r>
-              <a:rPr lang="en-US" sz="2400" dirty="0">
+              <a:rPr lang="en-US" sz="2800" dirty="0">
                 <a:solidFill>
                   <a:schemeClr val="bg1"/>
                 </a:solidFill>
@@ -5920,7 +5920,7 @@
               </a:rPr>
               <a:t>Local, privacy-focused evaluation</a:t>
             </a:r>
-            <a:endParaRPr lang="en-US" sz="2400" dirty="0">
+            <a:endParaRPr lang="en-US" sz="2800" dirty="0">
               <a:solidFill>
                 <a:schemeClr val="bg1"/>
               </a:solidFill>
@@ -5983,7 +5983,7 @@
           <a:lstStyle/>
           <a:p>
             <a:r>
-              <a:rPr lang="en-US" dirty="0">
+              <a:rPr lang="en-US" sz="1100" dirty="0">
                 <a:solidFill>
                   <a:schemeClr val="bg1"/>
                 </a:solidFill>
@@ -5991,10 +5991,10 @@
               <a:t>2</a:t>
             </a:r>
             <a:fld id="{CC057153-B650-4DEB-B370-79DDCFDCE934}" type="slidenum">
-              <a:rPr lang="en-US" smtClean="0"/>
+              <a:rPr lang="en-US" sz="1100" smtClean="0"/>
               <a:t>2</a:t>
             </a:fld>
-            <a:endParaRPr lang="en-US" dirty="0"/>
+            <a:endParaRPr lang="en-US" sz="1100" dirty="0"/>
           </a:p>
         </p:txBody>
       </p:sp>
@@ -6193,7 +6193,7 @@
           <a:lstStyle/>
           <a:p>
             <a:r>
-              <a:rPr lang="en-US" dirty="0">
+              <a:rPr lang="en-US" sz="1100" dirty="0">
                 <a:solidFill>
                   <a:schemeClr val="bg1"/>
                 </a:solidFill>
@@ -6201,14 +6201,11 @@
               <a:t>3</a:t>
             </a:r>
             <a:fld id="{CC057153-B650-4DEB-B370-79DDCFDCE934}" type="slidenum">
-              <a:rPr lang="en-US" smtClean="0"/>
+              <a:rPr lang="en-US" sz="1100" smtClean="0"/>
               <a:pPr/>
               <a:t>3</a:t>
             </a:fld>
-            <a:endParaRPr lang="en-US" dirty="0"/>
-          </a:p>
-          <a:p>
-            <a:endParaRPr lang="en-US" dirty="0"/>
+            <a:endParaRPr lang="en-US" sz="1100" dirty="0"/>
           </a:p>
         </p:txBody>
       </p:sp>
@@ -6397,14 +6394,14 @@
           <a:lstStyle/>
           <a:p>
             <a:fld id="{CC057153-B650-4DEB-B370-79DDCFDCE934}" type="slidenum">
-              <a:rPr lang="en-US" smtClean="0">
+              <a:rPr lang="en-US" sz="1100" smtClean="0">
                 <a:solidFill>
                   <a:schemeClr val="bg1"/>
                 </a:solidFill>
               </a:rPr>
               <a:t>4</a:t>
             </a:fld>
-            <a:endParaRPr lang="en-US" dirty="0">
+            <a:endParaRPr lang="en-US" sz="1100" dirty="0">
               <a:solidFill>
                 <a:schemeClr val="bg1"/>
               </a:solidFill>
@@ -6550,14 +6547,14 @@
           <a:lstStyle/>
           <a:p>
             <a:fld id="{CC057153-B650-4DEB-B370-79DDCFDCE934}" type="slidenum">
-              <a:rPr lang="en-US" smtClean="0">
+              <a:rPr lang="en-US" sz="1100" smtClean="0">
                 <a:solidFill>
                   <a:schemeClr val="bg1"/>
                 </a:solidFill>
               </a:rPr>
               <a:t>5</a:t>
             </a:fld>
-            <a:endParaRPr lang="en-US" dirty="0">
+            <a:endParaRPr lang="en-US" sz="1100" dirty="0">
               <a:solidFill>
                 <a:schemeClr val="bg1"/>
               </a:solidFill>
@@ -6793,14 +6790,14 @@
           <a:lstStyle/>
           <a:p>
             <a:fld id="{CC057153-B650-4DEB-B370-79DDCFDCE934}" type="slidenum">
-              <a:rPr lang="en-US" smtClean="0">
+              <a:rPr lang="en-US" sz="1100" smtClean="0">
                 <a:solidFill>
                   <a:schemeClr val="bg1"/>
                 </a:solidFill>
               </a:rPr>
               <a:t>6</a:t>
             </a:fld>
-            <a:endParaRPr lang="en-US" dirty="0">
+            <a:endParaRPr lang="en-US" sz="1100" dirty="0">
               <a:solidFill>
                 <a:schemeClr val="bg1"/>
               </a:solidFill>
@@ -7013,14 +7010,14 @@
           <a:lstStyle/>
           <a:p>
             <a:fld id="{CC057153-B650-4DEB-B370-79DDCFDCE934}" type="slidenum">
-              <a:rPr lang="en-US" smtClean="0">
+              <a:rPr lang="en-US" sz="1100" smtClean="0">
                 <a:solidFill>
                   <a:schemeClr val="bg1"/>
                 </a:solidFill>
               </a:rPr>
               <a:t>7</a:t>
             </a:fld>
-            <a:endParaRPr lang="en-US" dirty="0">
+            <a:endParaRPr lang="en-US" sz="1100" dirty="0">
               <a:solidFill>
                 <a:schemeClr val="bg1"/>
               </a:solidFill>
@@ -7028,6 +7025,42 @@
           </a:p>
         </p:txBody>
       </p:sp>
+      <p:pic>
+        <p:nvPicPr>
+          <p:cNvPr id="7" name="Picture 6">
+            <a:extLst>
+              <a:ext uri="{FF2B5EF4-FFF2-40B4-BE49-F238E27FC236}">
+                <a16:creationId xmlns:a16="http://schemas.microsoft.com/office/drawing/2014/main" id="{87E7D7D1-572F-2AF5-5FDA-1EEC00BDCE77}"/>
+              </a:ext>
+            </a:extLst>
+          </p:cNvPr>
+          <p:cNvPicPr>
+            <a:picLocks noChangeAspect="1"/>
+          </p:cNvPicPr>
+          <p:nvPr/>
+        </p:nvPicPr>
+        <p:blipFill>
+          <a:blip r:embed="rId4">
+            <a:extLst>
+              <a:ext uri="{28A0092B-C50C-407E-A947-70E740481C1C}">
+                <a14:useLocalDpi xmlns:a14="http://schemas.microsoft.com/office/drawing/2010/main" val="0"/>
+              </a:ext>
+            </a:extLst>
+          </a:blip>
+          <a:stretch>
+            <a:fillRect/>
+          </a:stretch>
+        </p:blipFill>
+        <p:spPr>
+          <a:xfrm>
+            <a:off x="7116682" y="228153"/>
+            <a:ext cx="4515480" cy="6401693"/>
+          </a:xfrm>
+          <a:prstGeom prst="rect">
+            <a:avLst/>
+          </a:prstGeom>
+        </p:spPr>
+      </p:pic>
     </p:spTree>
     <p:extLst>
       <p:ext uri="{BB962C8B-B14F-4D97-AF65-F5344CB8AC3E}">
@@ -7120,7 +7153,12 @@
             <p:ph idx="1"/>
           </p:nvPr>
         </p:nvSpPr>
-        <p:spPr/>
+        <p:spPr>
+          <a:xfrm>
+            <a:off x="612647" y="1715532"/>
+            <a:ext cx="5339745" cy="4593828"/>
+          </a:xfrm>
+        </p:spPr>
         <p:txBody>
           <a:bodyPr>
             <a:normAutofit/>
@@ -7229,14 +7267,14 @@
           <a:lstStyle/>
           <a:p>
             <a:fld id="{CC057153-B650-4DEB-B370-79DDCFDCE934}" type="slidenum">
-              <a:rPr lang="en-US" smtClean="0">
+              <a:rPr lang="en-US" sz="1100" smtClean="0">
                 <a:solidFill>
                   <a:schemeClr val="bg1"/>
                 </a:solidFill>
               </a:rPr>
               <a:t>8</a:t>
             </a:fld>
-            <a:endParaRPr lang="en-US" dirty="0">
+            <a:endParaRPr lang="en-US" sz="1100" dirty="0">
               <a:solidFill>
                 <a:schemeClr val="bg1"/>
               </a:solidFill>
@@ -7244,6 +7282,42 @@
           </a:p>
         </p:txBody>
       </p:sp>
+      <p:pic>
+        <p:nvPicPr>
+          <p:cNvPr id="9" name="Picture 8">
+            <a:extLst>
+              <a:ext uri="{FF2B5EF4-FFF2-40B4-BE49-F238E27FC236}">
+                <a16:creationId xmlns:a16="http://schemas.microsoft.com/office/drawing/2014/main" id="{6B96407D-8A84-DB11-EF37-378C9A5B6821}"/>
+              </a:ext>
+            </a:extLst>
+          </p:cNvPr>
+          <p:cNvPicPr>
+            <a:picLocks noChangeAspect="1"/>
+          </p:cNvPicPr>
+          <p:nvPr/>
+        </p:nvPicPr>
+        <p:blipFill>
+          <a:blip r:embed="rId4">
+            <a:extLst>
+              <a:ext uri="{28A0092B-C50C-407E-A947-70E740481C1C}">
+                <a14:useLocalDpi xmlns:a14="http://schemas.microsoft.com/office/drawing/2010/main" val="0"/>
+              </a:ext>
+            </a:extLst>
+          </a:blip>
+          <a:stretch>
+            <a:fillRect/>
+          </a:stretch>
+        </p:blipFill>
+        <p:spPr>
+          <a:xfrm>
+            <a:off x="6096000" y="356968"/>
+            <a:ext cx="5677043" cy="5952392"/>
+          </a:xfrm>
+          <a:prstGeom prst="rect">
+            <a:avLst/>
+          </a:prstGeom>
+        </p:spPr>
+      </p:pic>
     </p:spTree>
     <p:extLst>
       <p:ext uri="{BB962C8B-B14F-4D97-AF65-F5344CB8AC3E}">
@@ -7439,14 +7513,14 @@
           <a:lstStyle/>
           <a:p>
             <a:fld id="{CC057153-B650-4DEB-B370-79DDCFDCE934}" type="slidenum">
-              <a:rPr lang="en-US" smtClean="0">
+              <a:rPr lang="en-US" sz="1100" smtClean="0">
                 <a:solidFill>
                   <a:schemeClr val="bg1"/>
                 </a:solidFill>
               </a:rPr>
               <a:t>9</a:t>
             </a:fld>
-            <a:endParaRPr lang="en-US" dirty="0">
+            <a:endParaRPr lang="en-US" sz="1100" dirty="0">
               <a:solidFill>
                 <a:schemeClr val="bg1"/>
               </a:solidFill>

</xml_diff>